<commit_message>
Update folder layout and script name to run.py for i4c compliance
</commit_message>
<xml_diff>
--- a/PixelPioneers_KLA_PS01.pptx
+++ b/PixelPioneers_KLA_PS01.pptx
@@ -6601,7 +6601,7 @@
             </a:r>
             <a:br/>
             <a:r>
-              <a:t>• Checkpoint Size: 169.7 KB on disk (best_model.pt).</a:t>
+              <a:t>• Checkpoint Size: 169.7 KB on disk (models/best_model.pt).</a:t>
             </a:r>
             <a:br/>
             <a:r>
@@ -6999,7 +6999,7 @@
               </a:defRPr>
             </a:pPr>
             <a:r>
-              <a:t>• Public Model Checkpoint Weights (best_model.pt):</a:t>
+              <a:t>• Public Model Checkpoint Weights (models/best_model.pt):</a:t>
             </a:r>
             <a:br/>
             <a:r>
@@ -7041,11 +7041,11 @@
               </a:defRPr>
             </a:pPr>
             <a:r>
-              <a:t>• Phase 1 Portal Status:</a:t>
+              <a:t>• i4c Technical Check compliance:</a:t>
             </a:r>
             <a:br/>
             <a:r>
-              <a:t>  Submitted via official i4c Hackathon Portal before August 16, 2026 deadline.</a:t>
+              <a:t>  Modified entry point to run.py and weights to models/best_model.pt.</a:t>
             </a:r>
           </a:p>
         </p:txBody>
@@ -7119,7 +7119,7 @@
               </a:defRPr>
             </a:pPr>
             <a:r>
-              <a:t>[✓] Standalone Evaluation CLI (eval.py / eval_dun.py): Dynamic CLI flags, auto-fallback, zero crash.</a:t>
+              <a:t>[✓] Standalone Evaluation CLI (run.py / eval.py): Dynamic CLI flags, auto-fallback, zero crash.</a:t>
             </a:r>
           </a:p>
           <a:p>
@@ -7204,7 +7204,7 @@
               </a:defRPr>
             </a:pPr>
             <a:r>
-              <a:t>[✓] Benchmark Reports: final_report.md, walkthrough.md, and validation_metrics.csv.</a:t>
+              <a:t>[✓] Benchmark Reports: docs/final_report.md and docs/walkthrough.md.</a:t>
             </a:r>
           </a:p>
         </p:txBody>

</xml_diff>